<commit_message>
docs: report and presentation
</commit_message>
<xml_diff>
--- a/docs/presentation/energy_security_data_warehouse_presentation.pptx
+++ b/docs/presentation/energy_security_data_warehouse_presentation.pptx
@@ -334,6 +334,13 @@
           </p:nvPr>
         </p:nvSpPr>
         <p:spPr/>
+        <p:txBody>
+          <a:bodyPr/>
+          <a:lstStyle/>
+          <a:p>
+            <a:endParaRPr lang="en-US"/>
+          </a:p>
+        </p:txBody>
       </p:sp>
       <p:sp>
         <p:nvSpPr>
@@ -409,6 +416,13 @@
           </p:nvPr>
         </p:nvSpPr>
         <p:spPr/>
+        <p:txBody>
+          <a:bodyPr/>
+          <a:lstStyle/>
+          <a:p>
+            <a:endParaRPr lang="en-US"/>
+          </a:p>
+        </p:txBody>
       </p:sp>
       <p:sp>
         <p:nvSpPr>
@@ -484,6 +498,13 @@
           </p:nvPr>
         </p:nvSpPr>
         <p:spPr/>
+        <p:txBody>
+          <a:bodyPr/>
+          <a:lstStyle/>
+          <a:p>
+            <a:endParaRPr lang="en-US"/>
+          </a:p>
+        </p:txBody>
       </p:sp>
       <p:sp>
         <p:nvSpPr>
@@ -559,6 +580,13 @@
           </p:nvPr>
         </p:nvSpPr>
         <p:spPr/>
+        <p:txBody>
+          <a:bodyPr/>
+          <a:lstStyle/>
+          <a:p>
+            <a:endParaRPr lang="en-US"/>
+          </a:p>
+        </p:txBody>
       </p:sp>
       <p:sp>
         <p:nvSpPr>
@@ -634,6 +662,13 @@
           </p:nvPr>
         </p:nvSpPr>
         <p:spPr/>
+        <p:txBody>
+          <a:bodyPr/>
+          <a:lstStyle/>
+          <a:p>
+            <a:endParaRPr lang="en-US"/>
+          </a:p>
+        </p:txBody>
       </p:sp>
       <p:sp>
         <p:nvSpPr>
@@ -709,6 +744,13 @@
           </p:nvPr>
         </p:nvSpPr>
         <p:spPr/>
+        <p:txBody>
+          <a:bodyPr/>
+          <a:lstStyle/>
+          <a:p>
+            <a:endParaRPr lang="en-US"/>
+          </a:p>
+        </p:txBody>
       </p:sp>
       <p:sp>
         <p:nvSpPr>
@@ -784,6 +826,13 @@
           </p:nvPr>
         </p:nvSpPr>
         <p:spPr/>
+        <p:txBody>
+          <a:bodyPr/>
+          <a:lstStyle/>
+          <a:p>
+            <a:endParaRPr lang="en-US"/>
+          </a:p>
+        </p:txBody>
       </p:sp>
       <p:sp>
         <p:nvSpPr>
@@ -859,6 +908,13 @@
           </p:nvPr>
         </p:nvSpPr>
         <p:spPr/>
+        <p:txBody>
+          <a:bodyPr/>
+          <a:lstStyle/>
+          <a:p>
+            <a:endParaRPr lang="en-US"/>
+          </a:p>
+        </p:txBody>
       </p:sp>
       <p:sp>
         <p:nvSpPr>
@@ -934,6 +990,13 @@
           </p:nvPr>
         </p:nvSpPr>
         <p:spPr/>
+        <p:txBody>
+          <a:bodyPr/>
+          <a:lstStyle/>
+          <a:p>
+            <a:endParaRPr lang="en-US"/>
+          </a:p>
+        </p:txBody>
       </p:sp>
       <p:sp>
         <p:nvSpPr>
@@ -1009,6 +1072,13 @@
           </p:nvPr>
         </p:nvSpPr>
         <p:spPr/>
+        <p:txBody>
+          <a:bodyPr/>
+          <a:lstStyle/>
+          <a:p>
+            <a:endParaRPr lang="en-US"/>
+          </a:p>
+        </p:txBody>
       </p:sp>
       <p:sp>
         <p:nvSpPr>
@@ -1084,6 +1154,13 @@
           </p:nvPr>
         </p:nvSpPr>
         <p:spPr/>
+        <p:txBody>
+          <a:bodyPr/>
+          <a:lstStyle/>
+          <a:p>
+            <a:endParaRPr lang="en-US"/>
+          </a:p>
+        </p:txBody>
       </p:sp>
       <p:sp>
         <p:nvSpPr>
@@ -1159,6 +1236,13 @@
           </p:nvPr>
         </p:nvSpPr>
         <p:spPr/>
+        <p:txBody>
+          <a:bodyPr/>
+          <a:lstStyle/>
+          <a:p>
+            <a:endParaRPr lang="en-US"/>
+          </a:p>
+        </p:txBody>
       </p:sp>
       <p:sp>
         <p:nvSpPr>
@@ -4742,7 +4826,7 @@
         <p:spPr>
           <a:xfrm>
             <a:off x="1645920" y="2011680"/>
-            <a:ext cx="8869680" cy="1463040"/>
+            <a:ext cx="8869680" cy="902811"/>
           </a:xfrm>
           <a:prstGeom prst="rect">
             <a:avLst/>
@@ -4767,6 +4851,7 @@
               </a:defRPr>
             </a:pPr>
             <a:r>
+              <a:rPr dirty="0"/>
               <a:t>Energy Security Data Warehouse</a:t>
             </a:r>
           </a:p>
@@ -4786,7 +4871,8 @@
               </a:defRPr>
             </a:pPr>
             <a:r>
-              <a:t>A Fact Constellation Architecture for Analyzing Geopolitical Risk and Energy Resilience in Europe</a:t>
+              <a:rPr dirty="0"/>
+              <a:t>Analyzing Geopolitical Risk and Energy Resilience in Europe</a:t>
             </a:r>
           </a:p>
         </p:txBody>
@@ -4866,12 +4952,25 @@
             </a:r>
             <a:r>
               <a:rPr lang="it-IT" dirty="0"/>
-              <a:t>Prof. Domenico Lembo, Prof.ssa Antonella Poggi, </a:t>
+              <a:t>Prof. Domenico LEMBO, Prof.ssa Antonella POGGI, </a:t>
             </a:r>
             <a:r>
               <a:rPr dirty="0"/>
-              <a:t>Prof. Roberto Delfino</a:t>
-            </a:r>
+              <a:t>Prof. Roberto</a:t>
+            </a:r>
+            <a:r>
+              <a:rPr lang="it-IT" dirty="0"/>
+              <a:t> Maria</a:t>
+            </a:r>
+            <a:r>
+              <a:rPr dirty="0"/>
+              <a:t> D</a:t>
+            </a:r>
+            <a:r>
+              <a:rPr lang="it-IT" dirty="0"/>
+              <a:t>ELFINO</a:t>
+            </a:r>
+            <a:endParaRPr dirty="0"/>
           </a:p>
           <a:p>
             <a:pPr>
@@ -7084,8 +7183,21 @@
                   <a:srgbClr val="334155"/>
                 </a:solidFill>
               </a:rPr>
-              <a:t>Architecture is ready to integrate daily wholesale power exchange data (GME/EEX).</a:t>
-            </a:r>
+              <a:t>Architecture is ready to integrate daily wholesale power exchange data</a:t>
+            </a:r>
+            <a:r>
+              <a:rPr lang="it-IT" sz="1600" dirty="0">
+                <a:solidFill>
+                  <a:srgbClr val="334155"/>
+                </a:solidFill>
+              </a:rPr>
+              <a:t>.</a:t>
+            </a:r>
+            <a:endParaRPr sz="1600" dirty="0">
+              <a:solidFill>
+                <a:srgbClr val="334155"/>
+              </a:solidFill>
+            </a:endParaRPr>
           </a:p>
           <a:p>
             <a:pPr>
@@ -7564,7 +7676,7 @@
         <p:spPr>
           <a:xfrm>
             <a:off x="1005840" y="2080260"/>
-            <a:ext cx="5394960" cy="4023360"/>
+            <a:ext cx="5394960" cy="3262432"/>
           </a:xfrm>
           <a:prstGeom prst="rect">
             <a:avLst/>
@@ -7614,7 +7726,23 @@
                   <a:srgbClr val="334155"/>
                 </a:solidFill>
               </a:rPr>
-              <a:t>The outbreak of the Russo-Ukrainian war triggered historic disruptions in natural gas flows, causing TTF gas prices and electricity tariffs to skyrocket across Europe.</a:t>
+              <a:t>The outbreak of the Russo-Ukrainian war triggered historic disruptions in natural gas flows, causing TTF gas prices and electricity tariffs to </a:t>
+            </a:r>
+            <a:r>
+              <a:rPr lang="it-IT" sz="1250" dirty="0">
+                <a:solidFill>
+                  <a:srgbClr val="334155"/>
+                </a:solidFill>
+              </a:rPr>
+              <a:t>increase</a:t>
+            </a:r>
+            <a:r>
+              <a:rPr sz="1250" dirty="0">
+                <a:solidFill>
+                  <a:srgbClr val="334155"/>
+                </a:solidFill>
+              </a:rPr>
+              <a:t> across Europe.</a:t>
             </a:r>
           </a:p>
           <a:p>
@@ -7638,7 +7766,7 @@
                   <a:srgbClr val="334155"/>
                 </a:solidFill>
               </a:rPr>
-              <a:t>European member states experienced sharply divergent economic strains based on their baseline reliance on Russian pipeline infrastructure vs LNG alternatives.</a:t>
+              <a:t>European member states experienced divergent economic strains based on their baseline reliance on Russian pipeline infrastructure vs LNG alternatives.</a:t>
             </a:r>
           </a:p>
           <a:p>
@@ -8502,7 +8630,7 @@
         <p:spPr>
           <a:xfrm>
             <a:off x="4608576" y="3017520"/>
-            <a:ext cx="2971800" cy="2834640"/>
+            <a:ext cx="2971800" cy="1703030"/>
           </a:xfrm>
           <a:prstGeom prst="rect">
             <a:avLst/>
@@ -8525,7 +8653,15 @@
             </a:pPr>
             <a:r>
               <a:rPr dirty="0"/>
-              <a:t>ENERGY TARIFFS (GAS &amp; POWER)</a:t>
+              <a:t>ENERGY TARIFFS (GAS &amp; </a:t>
+            </a:r>
+            <a:r>
+              <a:rPr lang="it-IT" dirty="0"/>
+              <a:t>ELECTRICITY</a:t>
+            </a:r>
+            <a:r>
+              <a:rPr dirty="0"/>
+              <a:t>)</a:t>
             </a:r>
           </a:p>
           <a:p>
@@ -10206,7 +10342,19 @@
             </a:br>
             <a:r>
               <a:rPr sz="1200" dirty="0"/>
-              <a:t>• Theoretical Rule: Summing unit prices over semesters or summing percentage rates across nations produces nonsensical values.</a:t>
+              <a:t>• Theoretical Rule: Summing unit prices over semesters or summing percentage rates across nations produces no</a:t>
+            </a:r>
+            <a:r>
+              <a:rPr lang="it-IT" sz="1200" dirty="0"/>
+              <a:t>t </a:t>
+            </a:r>
+            <a:r>
+              <a:rPr lang="it-IT" sz="1200" dirty="0" err="1"/>
+              <a:t>relevant</a:t>
+            </a:r>
+            <a:r>
+              <a:rPr sz="1200" dirty="0"/>
+              <a:t> values.</a:t>
             </a:r>
             <a:br>
               <a:rPr sz="1200" dirty="0"/>
@@ -10625,7 +10773,7 @@
         <p:spPr>
           <a:xfrm>
             <a:off x="731520" y="621792"/>
-            <a:ext cx="10728655" cy="502920"/>
+            <a:ext cx="10728655" cy="338554"/>
           </a:xfrm>
           <a:prstGeom prst="rect">
             <a:avLst/>
@@ -10650,7 +10798,8 @@
               </a:defRPr>
             </a:pPr>
             <a:r>
-              <a:t>Planar Fact Constellation Schema (0 Overlaps &amp; 0 Crossings)</a:t>
+              <a:rPr dirty="0"/>
+              <a:t>Planar Fact Constellation Schema </a:t>
             </a:r>
           </a:p>
         </p:txBody>
@@ -10927,7 +11076,7 @@
         <p:spPr>
           <a:xfrm>
             <a:off x="914400" y="1645920"/>
-            <a:ext cx="2926080" cy="3590727"/>
+            <a:ext cx="2926080" cy="3893374"/>
           </a:xfrm>
           <a:prstGeom prst="rect">
             <a:avLst/>
@@ -10949,7 +11098,7 @@
               </a:defRPr>
             </a:pPr>
             <a:r>
-              <a:rPr sz="1400" dirty="0"/>
+              <a:rPr dirty="0"/>
               <a:t>Architecture Rationale</a:t>
             </a:r>
           </a:p>
@@ -10961,7 +11110,7 @@
               <a:buNone/>
             </a:pPr>
             <a:r>
-              <a:rPr sz="1200" b="1" dirty="0">
+              <a:rPr sz="1600" b="1" dirty="0">
                 <a:solidFill>
                   <a:srgbClr val="1E3A8A"/>
                 </a:solidFill>
@@ -10969,7 +11118,7 @@
               <a:t>• Why Fact Constellation? </a:t>
             </a:r>
             <a:r>
-              <a:rPr sz="1200" dirty="0">
+              <a:rPr sz="1600" dirty="0">
                 <a:solidFill>
                   <a:srgbClr val="334155"/>
                 </a:solidFill>
@@ -10985,7 +11134,7 @@
               <a:buNone/>
             </a:pPr>
             <a:r>
-              <a:rPr sz="1200" b="1" dirty="0">
+              <a:rPr sz="1600" b="1" dirty="0">
                 <a:solidFill>
                   <a:srgbClr val="1E3A8A"/>
                 </a:solidFill>
@@ -10993,28 +11142,12 @@
               <a:t>• Conformed Dimensions: </a:t>
             </a:r>
             <a:r>
-              <a:rPr sz="1200" dirty="0">
+              <a:rPr sz="1600" dirty="0">
                 <a:solidFill>
                   <a:srgbClr val="334155"/>
                 </a:solidFill>
               </a:rPr>
-              <a:t>Unified DIM_GEO_ENTITY (with special surrogate </a:t>
-            </a:r>
-            <a:r>
-              <a:rPr sz="1200" dirty="0" err="1">
-                <a:solidFill>
-                  <a:srgbClr val="334155"/>
-                </a:solidFill>
-              </a:rPr>
-              <a:t>geo_sk</a:t>
-            </a:r>
-            <a:r>
-              <a:rPr sz="1200" dirty="0">
-                <a:solidFill>
-                  <a:srgbClr val="334155"/>
-                </a:solidFill>
-              </a:rPr>
-              <a:t>=1 for GLOBAL) enables cross-fact drill-across.</a:t>
+              <a:t>Unified DIM_GEO_ENTITY enables cross-fact drill-across.</a:t>
             </a:r>
           </a:p>
           <a:p>
@@ -11025,7 +11158,7 @@
               <a:buNone/>
             </a:pPr>
             <a:r>
-              <a:rPr sz="1200" b="1" dirty="0">
+              <a:rPr sz="1600" b="1" dirty="0">
                 <a:solidFill>
                   <a:srgbClr val="1E3A8A"/>
                 </a:solidFill>
@@ -11033,36 +11166,12 @@
               <a:t>• Surrogate Keys: </a:t>
             </a:r>
             <a:r>
-              <a:rPr sz="1200" dirty="0">
+              <a:rPr sz="1600" dirty="0">
                 <a:solidFill>
                   <a:srgbClr val="334155"/>
                 </a:solidFill>
               </a:rPr>
-              <a:t>Every dimension uses integer surrogate keys (INT/BIGINT) for maximum join efficiency, completely decoupled from source IDs.</a:t>
-            </a:r>
-          </a:p>
-          <a:p>
-            <a:pPr>
-              <a:spcBef>
-                <a:spcPts val="1000"/>
-              </a:spcBef>
-              <a:buNone/>
-            </a:pPr>
-            <a:r>
-              <a:rPr sz="1200" b="1" dirty="0">
-                <a:solidFill>
-                  <a:srgbClr val="1E3A8A"/>
-                </a:solidFill>
-              </a:rPr>
-              <a:t>• Planar Layout: </a:t>
-            </a:r>
-            <a:r>
-              <a:rPr sz="1200" dirty="0">
-                <a:solidFill>
-                  <a:srgbClr val="334155"/>
-                </a:solidFill>
-              </a:rPr>
-              <a:t>Engineered with 0 line crossings and 0 box overlaps, guaranteeing academic clarity.</a:t>
+              <a:t>Every dimension uses integer surrogate keys for maximum join efficiency, completely decoupled from source IDs.</a:t>
             </a:r>
           </a:p>
         </p:txBody>
@@ -11793,7 +11902,7 @@
         <p:spPr>
           <a:xfrm>
             <a:off x="6492240" y="1645920"/>
-            <a:ext cx="4693615" cy="3908762"/>
+            <a:ext cx="4693615" cy="3662541"/>
           </a:xfrm>
           <a:prstGeom prst="rect">
             <a:avLst/>
@@ -12008,8 +12117,21 @@
                   <a:srgbClr val="334155"/>
                 </a:solidFill>
               </a:rPr>
-              <a:t> = FALSE from 2020 onward.</a:t>
-            </a:r>
+              <a:t> = FALSE from 2020</a:t>
+            </a:r>
+            <a:r>
+              <a:rPr lang="it-IT" sz="1600" dirty="0">
+                <a:solidFill>
+                  <a:srgbClr val="334155"/>
+                </a:solidFill>
+              </a:rPr>
+              <a:t>.</a:t>
+            </a:r>
+            <a:endParaRPr sz="1600" dirty="0">
+              <a:solidFill>
+                <a:srgbClr val="334155"/>
+              </a:solidFill>
+            </a:endParaRPr>
           </a:p>
           <a:p>
             <a:pPr>
@@ -12519,7 +12641,7 @@
         <p:spPr>
           <a:xfrm>
             <a:off x="914400" y="1645920"/>
-            <a:ext cx="3063240" cy="4175502"/>
+            <a:ext cx="3063240" cy="3493264"/>
           </a:xfrm>
           <a:prstGeom prst="rect">
             <a:avLst/>
@@ -12590,7 +12712,7 @@
                   <a:srgbClr val="334155"/>
                 </a:solidFill>
               </a:rPr>
-              <a:t>Flags ('p', 'e', 'b') preserved as descriptive attributes, keeping metrics numeric.</a:t>
+              <a:t>Flags preserved as descriptive attributes, keeping metrics numeric.</a:t>
             </a:r>
           </a:p>
           <a:p>
@@ -12615,46 +12737,6 @@
                 </a:solidFill>
               </a:rPr>
               <a:t>NL/CZ subsidies audited as legal tax credits, not ingestion bugs.</a:t>
-            </a:r>
-          </a:p>
-          <a:p>
-            <a:pPr>
-              <a:spcBef>
-                <a:spcPts val="1000"/>
-              </a:spcBef>
-              <a:buNone/>
-            </a:pPr>
-            <a:r>
-              <a:rPr b="1" dirty="0">
-                <a:solidFill>
-                  <a:srgbClr val="0F172A"/>
-                </a:solidFill>
-              </a:rPr>
-              <a:t>• Dependencies: </a:t>
-            </a:r>
-            <a:r>
-              <a:rPr dirty="0">
-                <a:solidFill>
-                  <a:srgbClr val="334155"/>
-                </a:solidFill>
-              </a:rPr>
-              <a:t>pandas, psycopg2-binary, </a:t>
-            </a:r>
-            <a:r>
-              <a:rPr dirty="0" err="1">
-                <a:solidFill>
-                  <a:srgbClr val="334155"/>
-                </a:solidFill>
-              </a:rPr>
-              <a:t>xlrd</a:t>
-            </a:r>
-            <a:r>
-              <a:rPr dirty="0">
-                <a:solidFill>
-                  <a:srgbClr val="334155"/>
-                </a:solidFill>
-              </a:rPr>
-              <a:t>.</a:t>
             </a:r>
           </a:p>
         </p:txBody>
@@ -12725,7 +12807,7 @@
         <p:spPr>
           <a:xfrm>
             <a:off x="4562856" y="1645920"/>
-            <a:ext cx="3063240" cy="4267835"/>
+            <a:ext cx="3063240" cy="3400931"/>
           </a:xfrm>
           <a:prstGeom prst="rect">
             <a:avLst/>
@@ -12837,30 +12919,6 @@
                 </a:solidFill>
               </a:rPr>
               <a:t>) and Windows (run_etl.ps1).</a:t>
-            </a:r>
-          </a:p>
-          <a:p>
-            <a:pPr>
-              <a:spcBef>
-                <a:spcPts val="1000"/>
-              </a:spcBef>
-              <a:buNone/>
-            </a:pPr>
-            <a:r>
-              <a:rPr sz="1600" b="1" dirty="0">
-                <a:solidFill>
-                  <a:srgbClr val="0F172A"/>
-                </a:solidFill>
-              </a:rPr>
-              <a:t>• Execution Time: </a:t>
-            </a:r>
-            <a:r>
-              <a:rPr sz="1600" dirty="0">
-                <a:solidFill>
-                  <a:srgbClr val="334155"/>
-                </a:solidFill>
-              </a:rPr>
-              <a:t>Complete ingestion from empty database executes in ~45 seconds.</a:t>
             </a:r>
           </a:p>
         </p:txBody>

</xml_diff>